<commit_message>
feat(build_slides): content-slide background from slides.json or the book's paper colour; drug-information decks on warm cream
Co-Authored-By: Claude Opus 5.5 <noreply@anthropic.com>
</commit_message>
<xml_diff>
--- a/projects/drug-information-practical/slides/ch01-drug-information-centre.pptx
+++ b/projects/drug-information-practical/slides/ch01-drug-information-centre.pptx
@@ -5564,7 +5564,7 @@
     <p:bg>
       <p:bgPr>
         <a:solidFill>
-          <a:srgbClr val="FFFFFF"/>
+          <a:srgbClr val="F5EDE3"/>
         </a:solidFill>
         <a:effectLst/>
       </p:bgPr>
@@ -5902,7 +5902,7 @@
     <p:bg>
       <p:bgPr>
         <a:solidFill>
-          <a:srgbClr val="FFFFFF"/>
+          <a:srgbClr val="F5EDE3"/>
         </a:solidFill>
         <a:effectLst/>
       </p:bgPr>
@@ -6752,7 +6752,7 @@
     <p:bg>
       <p:bgPr>
         <a:solidFill>
-          <a:srgbClr val="FFFFFF"/>
+          <a:srgbClr val="F5EDE3"/>
         </a:solidFill>
         <a:effectLst/>
       </p:bgPr>
@@ -7127,7 +7127,7 @@
     <p:bg>
       <p:bgPr>
         <a:solidFill>
-          <a:srgbClr val="FFFFFF"/>
+          <a:srgbClr val="F5EDE3"/>
         </a:solidFill>
         <a:effectLst/>
       </p:bgPr>
@@ -7475,7 +7475,7 @@
     <p:bg>
       <p:bgPr>
         <a:solidFill>
-          <a:srgbClr val="FFFFFF"/>
+          <a:srgbClr val="F5EDE3"/>
         </a:solidFill>
         <a:effectLst/>
       </p:bgPr>
@@ -8281,7 +8281,7 @@
     <p:bg>
       <p:bgPr>
         <a:solidFill>
-          <a:srgbClr val="FFFFFF"/>
+          <a:srgbClr val="F5EDE3"/>
         </a:solidFill>
         <a:effectLst/>
       </p:bgPr>
@@ -9130,7 +9130,7 @@
     <p:bg>
       <p:bgPr>
         <a:solidFill>
-          <a:srgbClr val="FFFFFF"/>
+          <a:srgbClr val="F5EDE3"/>
         </a:solidFill>
         <a:effectLst/>
       </p:bgPr>
@@ -9936,7 +9936,7 @@
     <p:bg>
       <p:bgPr>
         <a:solidFill>
-          <a:srgbClr val="FFFFFF"/>
+          <a:srgbClr val="F5EDE3"/>
         </a:solidFill>
         <a:effectLst/>
       </p:bgPr>
@@ -10785,7 +10785,7 @@
     <p:bg>
       <p:bgPr>
         <a:solidFill>
-          <a:srgbClr val="FFFFFF"/>
+          <a:srgbClr val="F5EDE3"/>
         </a:solidFill>
         <a:effectLst/>
       </p:bgPr>
@@ -11591,7 +11591,7 @@
     <p:bg>
       <p:bgPr>
         <a:solidFill>
-          <a:srgbClr val="FFFFFF"/>
+          <a:srgbClr val="F5EDE3"/>
         </a:solidFill>
         <a:effectLst/>
       </p:bgPr>
@@ -12440,7 +12440,7 @@
     <p:bg>
       <p:bgPr>
         <a:solidFill>
-          <a:srgbClr val="FFFFFF"/>
+          <a:srgbClr val="F5EDE3"/>
         </a:solidFill>
         <a:effectLst/>
       </p:bgPr>
@@ -13178,7 +13178,7 @@
     <p:bg>
       <p:bgPr>
         <a:solidFill>
-          <a:srgbClr val="FFFFFF"/>
+          <a:srgbClr val="F5EDE3"/>
         </a:solidFill>
         <a:effectLst/>
       </p:bgPr>
@@ -13984,7 +13984,7 @@
     <p:bg>
       <p:bgPr>
         <a:solidFill>
-          <a:srgbClr val="FFFFFF"/>
+          <a:srgbClr val="F5EDE3"/>
         </a:solidFill>
         <a:effectLst/>
       </p:bgPr>
@@ -14833,7 +14833,7 @@
     <p:bg>
       <p:bgPr>
         <a:solidFill>
-          <a:srgbClr val="FFFFFF"/>
+          <a:srgbClr val="F5EDE3"/>
         </a:solidFill>
         <a:effectLst/>
       </p:bgPr>
@@ -15639,7 +15639,7 @@
     <p:bg>
       <p:bgPr>
         <a:solidFill>
-          <a:srgbClr val="FFFFFF"/>
+          <a:srgbClr val="F5EDE3"/>
         </a:solidFill>
         <a:effectLst/>
       </p:bgPr>
@@ -16488,7 +16488,7 @@
     <p:bg>
       <p:bgPr>
         <a:solidFill>
-          <a:srgbClr val="FFFFFF"/>
+          <a:srgbClr val="F5EDE3"/>
         </a:solidFill>
         <a:effectLst/>
       </p:bgPr>
@@ -17341,7 +17341,7 @@
     <p:bg>
       <p:bgPr>
         <a:solidFill>
-          <a:srgbClr val="FFFFFF"/>
+          <a:srgbClr val="F5EDE3"/>
         </a:solidFill>
         <a:effectLst/>
       </p:bgPr>
@@ -17929,7 +17929,7 @@
     <p:bg>
       <p:bgPr>
         <a:solidFill>
-          <a:srgbClr val="FFFFFF"/>
+          <a:srgbClr val="F5EDE3"/>
         </a:solidFill>
         <a:effectLst/>
       </p:bgPr>
@@ -18457,7 +18457,7 @@
     <p:bg>
       <p:bgPr>
         <a:solidFill>
-          <a:srgbClr val="FFFFFF"/>
+          <a:srgbClr val="F5EDE3"/>
         </a:solidFill>
         <a:effectLst/>
       </p:bgPr>
@@ -19010,7 +19010,7 @@
     <p:bg>
       <p:bgPr>
         <a:solidFill>
-          <a:srgbClr val="FFFFFF"/>
+          <a:srgbClr val="F5EDE3"/>
         </a:solidFill>
         <a:effectLst/>
       </p:bgPr>
@@ -19552,7 +19552,7 @@
     <p:bg>
       <p:bgPr>
         <a:solidFill>
-          <a:srgbClr val="FFFFFF"/>
+          <a:srgbClr val="F5EDE3"/>
         </a:solidFill>
         <a:effectLst/>
       </p:bgPr>
@@ -20176,7 +20176,7 @@
     <p:bg>
       <p:bgPr>
         <a:solidFill>
-          <a:srgbClr val="FFFFFF"/>
+          <a:srgbClr val="F5EDE3"/>
         </a:solidFill>
         <a:effectLst/>
       </p:bgPr>
@@ -20750,7 +20750,7 @@
     <p:bg>
       <p:bgPr>
         <a:solidFill>
-          <a:srgbClr val="FFFFFF"/>
+          <a:srgbClr val="F5EDE3"/>
         </a:solidFill>
         <a:effectLst/>
       </p:bgPr>

</xml_diff>